<commit_message>
Soften participant copy so it reads as an invitation, not a briefing.
Keep the practical constraints (install ahead, conference wifi, jump-ahead
outputs) but drop the clipped rules and ranking of tracks.
</commit_message>
<xml_diff>
--- a/slides/ISSW2026_autoATES_workshop_observer.pptx
+++ b/slides/ISSW2026_autoATES_workshop_observer.pptx
@@ -777,7 +777,7 @@
           <a:p>
             <a:r>
               <a:rPr lang="en-US" dirty="0"/>
-              <a:t>Do not start a second live AOI. South Coast is QGIS-only if the extra zip is present.</a:t>
+              <a:t>We will not start a second live AOI. South Coast is QGIS-only if that extra is present.</a:t>
             </a:r>
             <a:endParaRPr lang="en-US" dirty="0"/>
           </a:p>
@@ -953,7 +953,7 @@
           <a:p>
             <a:r>
               <a:rPr lang="en-US" dirty="0"/>
-              <a:t>Typical vs infrequent is the v3.0 design. Do not retune class thresholds live.</a:t>
+              <a:t>Typical vs infrequent is the v3.0 design. Keep the ISSW thresholds for this session.</a:t>
             </a:r>
             <a:endParaRPr lang="en-US" dirty="0"/>
           </a:p>
@@ -1393,7 +1393,7 @@
           <a:p>
             <a:r>
               <a:rPr lang="en-US" dirty="0"/>
-              <a:t>Published v2 sits on the calibration envelope. Do not retune thresholds live.</a:t>
+              <a:t>Published v2 sits on the calibration envelope. Keep the ISSW thresholds for this session.</a:t>
             </a:r>
             <a:endParaRPr lang="en-US" dirty="0"/>
           </a:p>
@@ -2004,7 +2004,7 @@
                 <a:ea typeface="Calibri" pitchFamily="34" charset="-122"/>
                 <a:cs typeface="Calibri" pitchFamily="34" charset="-120"/>
               </a:rPr>
-              <a:t>Follow along on a laptop, or sit and watch. Both tracks are first-class.</a:t>
+              <a:t>You can run the notebooks on a laptop, or follow the same maps on the projector.</a:t>
             </a:r>
             <a:endParaRPr lang="en-US" sz="1600" dirty="0"/>
           </a:p>
@@ -3316,7 +3316,7 @@
                 <a:ea typeface="Calibri" pitchFamily="34" charset="-122"/>
                 <a:cs typeface="Calibri" pitchFamily="34" charset="-120"/>
               </a:rPr>
-              <a:t>Follow along</a:t>
+              <a:t>On a laptop</a:t>
             </a:r>
             <a:endParaRPr lang="en-US" sz="2200" dirty="0"/>
           </a:p>
@@ -3355,7 +3355,7 @@
                 <a:ea typeface="Calibri" pitchFamily="34" charset="-122"/>
                 <a:cs typeface="Calibri" pitchFamily="34" charset="-120"/>
               </a:rPr>
-              <a:t>Run the notebook for the current module. Python 3.11 + QGIS. If a step fails, copy that folder’s outputs_reference and continue.</a:t>
+              <a:t>Run the notebook for the current module (Python 3.11 + QGIS). If a step stalls, copy that folder’s outputs_reference and continue with the group.</a:t>
             </a:r>
             <a:endParaRPr lang="en-US" sz="1600" dirty="0"/>
           </a:p>
@@ -3419,7 +3419,7 @@
                 <a:ea typeface="Calibri" pitchFamily="34" charset="-122"/>
                 <a:cs typeface="Calibri" pitchFamily="34" charset="-120"/>
               </a:rPr>
-              <a:t>Observe</a:t>
+              <a:t>Watching</a:t>
             </a:r>
             <a:endParaRPr lang="en-US" sz="2200" dirty="0"/>
           </a:p>
@@ -3458,7 +3458,7 @@
                 <a:ea typeface="Calibri" pitchFamily="34" charset="-122"/>
                 <a:cs typeface="Calibri" pitchFamily="34" charset="-120"/>
               </a:rPr>
-              <a:t>Same maps on this screen. No laptop required. You leave with the method, the design choices, and where to get the code.</a:t>
+              <a:t>The same maps are on this screen. A laptop is optional. You leave with the method, the design choices, and where to get the code.</a:t>
             </a:r>
             <a:endParaRPr lang="en-US" sz="1600" dirty="0"/>
           </a:p>
@@ -3522,7 +3522,7 @@
                 <a:ea typeface="Calibri" pitchFamily="34" charset="-122"/>
                 <a:cs typeface="Calibri" pitchFamily="34" charset="-120"/>
               </a:rPr>
-              <a:t>Jump ahead</a:t>
+              <a:t>If a step stalls</a:t>
             </a:r>
             <a:endParaRPr lang="en-US" sz="2200" dirty="0"/>
           </a:p>
@@ -3561,7 +3561,7 @@
                 <a:ea typeface="Calibri" pitchFamily="34" charset="-122"/>
                 <a:cs typeface="Calibri" pitchFamily="34" charset="-120"/>
               </a:rPr>
-              <a:t>data/&lt;step&gt;/outputs_reference/ is the recovery path. Helpers will not stop the room for one laptop.</a:t>
+              <a:t>data/&lt;step&gt;/outputs_reference/ lets you stay with the room. Helpers will keep the day moving so the afternoon still fits.</a:t>
             </a:r>
             <a:endParaRPr lang="en-US" sz="1600" dirty="0"/>
           </a:p>
@@ -3600,7 +3600,7 @@
                 <a:ea typeface="Calibri" pitchFamily="34" charset="-122"/>
                 <a:cs typeface="Calibri" pitchFamily="34" charset="-120"/>
               </a:rPr>
-              <a:t>Helpers from 08:15. USB copies at the door. Conference wifi is not a plan.</a:t>
+              <a:t>Helpers from 08:15, with USB copies. Please download the folders before Saturday if you can — conference wifi is often slow.</a:t>
             </a:r>
             <a:endParaRPr lang="en-US" sz="1600" dirty="0"/>
           </a:p>

</xml_diff>

<commit_message>
Put the dev8 Connaught map on the projector slides.
The reference rasters were already dev8. The slide figure, both decks,
and the orientation fallback RGB were still the previous classifier.
Adds the ten-slide afternoon opener.
</commit_message>
<xml_diff>
--- a/slides/ISSW2026_autoATES_workshop_observer.pptx
+++ b/slides/ISSW2026_autoATES_workshop_observer.pptx
@@ -601,7 +601,7 @@
           <a:p>
             <a:r>
               <a:rPr lang="en-US" dirty="0"/>
-              <a:t>Live call is atesCore. Paper hybrid is atesValidation. Class 0 is a safety decision. Discuss next to the expert overlay; do not score as an exam.</a:t>
+              <a:t>This raster is dev8: split votes, then reach floors. Class 0 is a safety decision. Discuss next to the expert overlay; do not score as an exam.</a:t>
             </a:r>
             <a:endParaRPr lang="en-US" dirty="0"/>
           </a:p>
@@ -2122,7 +2122,7 @@
       </p:sp>
       <p:pic>
         <p:nvPicPr>
-          <p:cNvPr id="4" name="Image 0" descr="/home/jmsykes/Documents/Code/issw2026-autoates-workshop/slides/figures/ates_finished.png">    </p:cNvPr>
+          <p:cNvPr id="4" name="Image 0" descr="/home/sykes-sfu/Documents/Code/ATES/issw-workshop/issw2026-autoates-workshop/slides/figures/ates_finished.png">    </p:cNvPr>
           <p:cNvPicPr>
             <a:picLocks noChangeAspect="1"/>
           </p:cNvPicPr>
@@ -4708,7 +4708,7 @@
       </p:sp>
       <p:pic>
         <p:nvPicPr>
-          <p:cNvPr id="4" name="Image 0" descr="/home/jmsykes/Documents/Code/issw2026-autoates-workshop/slides/figures/ates_finished.png">    </p:cNvPr>
+          <p:cNvPr id="4" name="Image 0" descr="/home/sykes-sfu/Documents/Code/ATES/issw-workshop/issw2026-autoates-workshop/slides/figures/ates_finished.png">    </p:cNvPr>
           <p:cNvPicPr>
             <a:picLocks noChangeAspect="1"/>
           </p:cNvPicPr>
@@ -4920,7 +4920,7 @@
       </p:sp>
       <p:pic>
         <p:nvPicPr>
-          <p:cNvPr id="4" name="Image 0" descr="/home/jmsykes/Documents/Code/issw2026-autoates-workshop/slides/figures/elev_hillshade.png">    </p:cNvPr>
+          <p:cNvPr id="4" name="Image 0" descr="/home/sykes-sfu/Documents/Code/ATES/issw-workshop/issw2026-autoates-workshop/slides/figures/elev_hillshade.png">    </p:cNvPr>
           <p:cNvPicPr>
             <a:picLocks noChangeAspect="1"/>
           </p:cNvPicPr>
@@ -5132,7 +5132,7 @@
       </p:sp>
       <p:pic>
         <p:nvPicPr>
-          <p:cNvPr id="4" name="Image 0" descr="/home/jmsykes/Documents/Code/issw2026-autoates-workshop/slides/figures/forest_seasons.png">    </p:cNvPr>
+          <p:cNvPr id="4" name="Image 0" descr="/home/sykes-sfu/Documents/Code/ATES/issw-workshop/issw2026-autoates-workshop/slides/figures/forest_seasons.png">    </p:cNvPr>
           <p:cNvPicPr>
             <a:picLocks noChangeAspect="1"/>
           </p:cNvPicPr>
@@ -5344,7 +5344,7 @@
       </p:sp>
       <p:pic>
         <p:nvPicPr>
-          <p:cNvPr id="4" name="Image 0" descr="/home/jmsykes/Documents/Code/issw2026-autoates-workshop/slides/figures/forest_cover_gap.png">    </p:cNvPr>
+          <p:cNvPr id="4" name="Image 0" descr="/home/sykes-sfu/Documents/Code/ATES/issw-workshop/issw2026-autoates-workshop/slides/figures/forest_cover_gap.png">    </p:cNvPr>
           <p:cNvPicPr>
             <a:picLocks noChangeAspect="1"/>
           </p:cNvPicPr>
@@ -5556,7 +5556,7 @@
       </p:sp>
       <p:pic>
         <p:nvPicPr>
-          <p:cNvPr id="4" name="Image 0" descr="/home/jmsykes/Documents/Code/issw2026-autoates-workshop/slides/figures/pra_two_scenarios.png">    </p:cNvPr>
+          <p:cNvPr id="4" name="Image 0" descr="/home/sykes-sfu/Documents/Code/ATES/issw-workshop/issw2026-autoates-workshop/slides/figures/pra_two_scenarios.png">    </p:cNvPr>
           <p:cNvPicPr>
             <a:picLocks noChangeAspect="1"/>
           </p:cNvPicPr>
@@ -5768,7 +5768,7 @@
       </p:sp>
       <p:pic>
         <p:nvPicPr>
-          <p:cNvPr id="4" name="Image 0" descr="/home/jmsykes/Documents/Code/issw2026-autoates-workshop/slides/figures/runout_two_scenarios.png">    </p:cNvPr>
+          <p:cNvPr id="4" name="Image 0" descr="/home/sykes-sfu/Documents/Code/ATES/issw-workshop/issw2026-autoates-workshop/slides/figures/runout_two_scenarios.png">    </p:cNvPr>
           <p:cNvPicPr>
             <a:picLocks noChangeAspect="1"/>
           </p:cNvPicPr>

</xml_diff>